<commit_message>
Use scdl_my_sql_data as the MySQL Docker volume name everywhere
Co-Authored-By: Claude Opus 5.5 <noreply@anthropic.com>
</commit_message>
<xml_diff>
--- a/Low-Code-No-Code/no-code-low-code-2.pptx
+++ b/Low-Code-No-Code/no-code-low-code-2.pptx
@@ -22287,7 +22287,7 @@
                 <a:ea typeface="Courier New" pitchFamily="34" charset="-122"/>
                 <a:cs typeface="Courier New" pitchFamily="34" charset="-120"/>
               </a:rPr>
-              <a:t>docker volume create mysql_data</a:t>
+              <a:t>docker volume create scdl_my_sql_data</a:t>
             </a:r>
             <a:endParaRPr lang="en-US" sz="900" dirty="0"/>
           </a:p>
@@ -22372,7 +22372,7 @@
                 <a:ea typeface="Courier New" pitchFamily="34" charset="-122"/>
                 <a:cs typeface="Courier New" pitchFamily="34" charset="-120"/>
               </a:rPr>
-              <a:t>  -v mysql_data:/var/lib/mysql mysql:8.4</a:t>
+              <a:t>  -v scdl_my_sql_data:/var/lib/mysql mysql:8.4</a:t>
             </a:r>
             <a:endParaRPr lang="en-US" sz="900" dirty="0"/>
           </a:p>

</xml_diff>